<commit_message>
Orchestrate the agent graph with LangGraph
Replace the hand-written state machine in graph.py with a LangGraph
StateGraph. Agents remain plain State -> State functions; a single
_traced wrapper records each AgentStep, and routers are now pure (the
judge retry decision lives in the Judge node as `retry`/`attempt`).
State fields that lacked annotations are now typed channels.

Output is unchanged: identical responses and traces on 28 golden and
edge-case queries, and identical rules-mode eval metrics. A failing
node no longer turns into a 500 when building the response.

Adds tests/test_graph.py (topology, early exits, judge retry, node
failure), langgraph to requirements, and updates the design document,
READMEs, API docs, presentation deck and regenerated PDFs.

Co-Authored-By: Claude Opus 5.5 <noreply@anthropic.com>
</commit_message>
<xml_diff>
--- a/presentation/Project_Presentation.pptx
+++ b/presentation/Project_Presentation.pptx
@@ -2044,7 +2044,7 @@
           <a:p>
             <a:r>
               <a:rPr lang="en-US" dirty="0"/>
-              <a:t>The architecture has three lanes. The top lane runs offline: the Ames data is cleaned, each row becomes one natural-language property case, and those cases are embedded with bge-small into a FAISS index alongside a BM25 index. The same data trains a gradient-boosting pricing model and a hedonic regression, and populates a metadata store for hard filters. The middle lane is the online path: FastAPI runs a typed state graph of eight agents, with a fallback chain from Claude Haiku to Sonnet to pure rules. Note the dashed red loop: if the judge rejects, we retry retrieval once with a bigger pool. The bottom lane is the quality loop: user feedback lands in SQLite, becomes golden cases, and feeds the evaluation dashboard.</a:t>
+              <a:t>The architecture has three lanes. The top lane runs offline: the Ames data is cleaned, each row becomes one natural-language property case, and those cases are embedded with bge-small into a FAISS index alongside a BM25 index. The same data trains a gradient-boosting pricing model and a hedonic regression, and populates a metadata store for hard filters. The middle lane is the online path: FastAPI runs a LangGraph state graph of eight agents, with a fallback chain from Claude Haiku to Sonnet to pure rules. Note the dashed red loop: if the judge rejects, we retry retrieval once with a bigger pool. The bottom lane is the quality loop: user feedback lands in SQLite, becomes golden cases, and feeds the evaluation dashboard.</a:t>
             </a:r>
             <a:endParaRPr lang="en-US" dirty="0"/>
           </a:p>
@@ -2396,7 +2396,7 @@
           <a:p>
             <a:r>
               <a:rPr lang="en-US" dirty="0"/>
-              <a:t>The agents run as a typed state graph, and every node is traced with its duration. The guardrail blocks prompt injection, redacts emails, SSNs and phone numbers, and clamps impossible values. The classifier is the main LLM step, extracting one of six intents plus attributes, with regex back-fill. The retriever fuses BM25 and FAISS by reciprocal rank. The comp analyst applies appraisal priorities and computes dollar adjustments. The pricing model and valuer produce the estimate, and the risk analyst turns five signals into a 0-to-100 score. The judge scores five criteria: comparable relevance, model agreement within ten percent, adjustment reasonableness, where any net adjustment beyond plus or minus thirty percent is flagged, grounded narrative, and range calibration. Deterministic checks bound its score, and an ungrounded figure forces a rejection. A rejection sends us back to retrieval once with double the candidates.</a:t>
+              <a:t>The agents run as a LangGraph state graph, and every node is traced with its duration. The guardrail blocks prompt injection, redacts emails, SSNs and phone numbers, and clamps impossible values. The classifier is the main LLM step, extracting one of six intents plus attributes, with regex back-fill. The retriever fuses BM25 and FAISS by reciprocal rank. The comp analyst applies appraisal priorities and computes dollar adjustments. The pricing model and valuer produce the estimate, and the risk analyst turns five signals into a 0-to-100 score. The judge scores five criteria: comparable relevance, model agreement within ten percent, adjustment reasonableness, where any net adjustment beyond plus or minus thirty percent is flagged, grounded narrative, and range calibration. Deterministic checks bound its score, and an ungrounded figure forces a rejection. A rejection sends us back to retrieval once with double the candidates.</a:t>
             </a:r>
             <a:endParaRPr lang="en-US" dirty="0"/>
           </a:p>
@@ -13226,7 +13226,7 @@
                   <a:schemeClr val="tx2"/>
                 </a:solidFill>
               </a:rPr>
-              <a:t>FastAPI → typed state graph of 8 agents, each node traced with its duration.</a:t>
+              <a:t>FastAPI → LangGraph StateGraph of 8 agents, each node traced with its duration.</a:t>
             </a:r>
             <a:endParaRPr lang="en-US" sz="1200" dirty="0"/>
           </a:p>
@@ -14700,7 +14700,7 @@
                   <a:schemeClr val="tx2"/>
                 </a:solidFill>
               </a:rPr>
-              <a:t>8-node typed state graph, each node traced</a:t>
+              <a:t>8 LangGraph nodes, each traced</a:t>
             </a:r>
             <a:endParaRPr lang="en-US" sz="1200" dirty="0"/>
           </a:p>
@@ -15637,7 +15637,7 @@
                   <a:schemeClr val="tx2"/>
                 </a:solidFill>
               </a:rPr>
-              <a:t>Anthropic SDK</a:t>
+              <a:t>Anthropic SDK · LangGraph</a:t>
             </a:r>
             <a:endParaRPr lang="en-US" sz="1400" dirty="0"/>
           </a:p>
@@ -16697,7 +16697,7 @@
                 <a:ea typeface="+mj-lt" pitchFamily="34" charset="-122"/>
                 <a:cs typeface="+mj-lt" pitchFamily="34" charset="-120"/>
               </a:rPr>
-              <a:t>Eight agents on a typed state graph</a:t>
+              <a:t>Eight agents on a LangGraph state graph</a:t>
             </a:r>
             <a:endParaRPr lang="en-US" sz="3200" dirty="0"/>
           </a:p>

</xml_diff>

<commit_message>
Refine agents, sync docs and deck with latest evaluation, fix lint
- Agents: first-mentioned neighborhood wins, "no garage"/"no basement" parsing,
  plus comparables, judge, pricing and valuer refinements with tests
- Evaluation: refreshed results (61 cases, MAPE 9.6 %, range 80 %,
  precision/recall 91 %/97 %); docs and PDFs regenerated
- Presentation: slides 11-12 and speaker notes updated to the current
  metrics, latency and 64-test count
- Frontend: resolve the four eslint errors (theme toggle via
  useSyncExternalStore, derived compare loading state, typewriter
  rollover in a timeout, escaped apostrophe)

Co-Authored-By: Claude Opus 5.5 <noreply@anthropic.com>
</commit_message>
<xml_diff>
--- a/presentation/Project_Presentation.pptx
+++ b/presentation/Project_Presentation.pptx
@@ -1428,7 +1428,7 @@
           <a:p>
             <a:r>
               <a:rPr lang="en-US" dirty="0"/>
-              <a:t>On quality: the built-in runner scores 61 cases, 60 golden plus one that came from a human correction in the feedback loop. It's a hold-out setup, so a property is never its own comparable, and it uses no LLM calls, so it's free and reproducible. Valuation error is 9.8% MAPE against a 15% threshold, and the true price falls inside our range 82% of the time. Retrieval context precision is 84% and recall 91%. Faithfulness is 100%: every figure traces to evidence, so hallucination is zero. Intent accuracy is 98%, guardrails 100%, and median latency is 137 milliseconds. Separately, the pricing model cross-validates at 9.5% MAPE and R-squared 0.89, and all 44 automated tests pass. The LLM-graded DeepEval results are in the evaluation report.</a:t>
+              <a:t>On quality: the built-in runner scores 61 cases, 60 golden plus one that came from a human correction in the feedback loop. It's a hold-out setup, so a property is never its own comparable, and it uses no LLM calls, so it's free and reproducible. Valuation error is 9.6% MAPE against a 15% threshold, and the true price falls inside our range 80% of the time. Retrieval context precision is 91% and recall 97%. Faithfulness is 100%: every figure traces to evidence, so hallucination is zero. Intent accuracy is 98%, guardrails 100%, and median latency is 124 milliseconds. Separately, the pricing model cross-validates at 9.6% MAPE and R-squared 0.89, and all 64 automated tests pass. The LLM-graded DeepEval results are in the evaluation report.</a:t>
             </a:r>
             <a:endParaRPr lang="en-US" dirty="0"/>
           </a:p>
@@ -1516,7 +1516,7 @@
           <a:p>
             <a:r>
               <a:rPr lang="en-US" dirty="0"/>
-              <a:t>For the embedding model, I benchmarked four encoders on 55 golden queries, top-10, without filters and with hold-out. Dense-only, bge-small has the best precision at 10, 0.649, and the best MRR, 0.753. It beats bge-base, which is twice its size, and runs at 10 milliseconds per query against 27. Adding BM25 through reciprocal-rank fusion lifts every encoder, because BM25 is very good at exact tokens like neighborhood codes and years. So the production choice is bge-small plus BM25. These are raw retrieval numbers. In the full pipeline, hard metadata filters and comparable prioritization raise contextual precision to 84%.</a:t>
+              <a:t>For the embedding model, I benchmarked four encoders on 55 golden queries, top-10, without filters and with hold-out. Dense-only, bge-small has the best precision at 10, 0.649, and the best MRR, 0.753. It beats bge-base, which is twice its size, and runs at 10 milliseconds per query against 27. Adding BM25 through reciprocal-rank fusion lifts every encoder, because BM25 is very good at exact tokens like neighborhood codes and years. So the production choice is bge-small plus BM25. These are raw retrieval numbers. In the full pipeline, hard metadata filters and comparable prioritization raise contextual precision to 91%.</a:t>
             </a:r>
             <a:endParaRPr lang="en-US" dirty="0"/>
           </a:p>
@@ -4952,7 +4952,7 @@
                 <a:ea typeface="+mj-lt" pitchFamily="34" charset="-122"/>
                 <a:cs typeface="+mj-lt" pitchFamily="34" charset="-120"/>
               </a:rPr>
-              <a:t>9.8%</a:t>
+              <a:t>9.6%</a:t>
             </a:r>
             <a:endParaRPr lang="en-US" sz="3400" dirty="0"/>
           </a:p>
@@ -5101,7 +5101,7 @@
                 <a:ea typeface="+mj-lt" pitchFamily="34" charset="-122"/>
                 <a:cs typeface="+mj-lt" pitchFamily="34" charset="-120"/>
               </a:rPr>
-              <a:t>82%</a:t>
+              <a:t>80%</a:t>
             </a:r>
             <a:endParaRPr lang="en-US" sz="3400" dirty="0"/>
           </a:p>
@@ -5250,7 +5250,7 @@
                 <a:ea typeface="+mj-lt" pitchFamily="34" charset="-122"/>
                 <a:cs typeface="+mj-lt" pitchFamily="34" charset="-120"/>
               </a:rPr>
-              <a:t>84%</a:t>
+              <a:t>91%</a:t>
             </a:r>
             <a:endParaRPr lang="en-US" sz="3400" dirty="0"/>
           </a:p>
@@ -5322,7 +5322,7 @@
                   <a:schemeClr val="accent2"/>
                 </a:solidFill>
               </a:rPr>
-              <a:t>recall 91%</a:t>
+              <a:t>recall 97%</a:t>
             </a:r>
             <a:endParaRPr lang="en-US" sz="1100" dirty="0"/>
           </a:p>
@@ -5548,7 +5548,7 @@
                 <a:ea typeface="+mj-lt" pitchFamily="34" charset="-122"/>
                 <a:cs typeface="+mj-lt" pitchFamily="34" charset="-120"/>
               </a:rPr>
-              <a:t>98%</a:t>
+              <a:t>100%</a:t>
             </a:r>
             <a:endParaRPr lang="en-US" sz="3400" dirty="0"/>
           </a:p>
@@ -5995,7 +5995,7 @@
                 <a:ea typeface="+mj-lt" pitchFamily="34" charset="-122"/>
                 <a:cs typeface="+mj-lt" pitchFamily="34" charset="-120"/>
               </a:rPr>
-              <a:t>137 ms</a:t>
+              <a:t>124 ms</a:t>
             </a:r>
             <a:endParaRPr lang="en-US" sz="3400" dirty="0"/>
           </a:p>
@@ -6067,7 +6067,7 @@
                   <a:schemeClr val="accent2"/>
                 </a:solidFill>
               </a:rPr>
-              <a:t>p95 176 ms</a:t>
+              <a:t>p95 156 ms</a:t>
             </a:r>
             <a:endParaRPr lang="en-US" sz="1100" dirty="0"/>
           </a:p>
@@ -6174,7 +6174,7 @@
                   <a:schemeClr val="tx2"/>
                 </a:solidFill>
               </a:rPr>
-              <a:t>Pricing model, 5-fold CV: MAPE 9.5%, R² 0.89</a:t>
+              <a:t>Pricing model, 5-fold CV: MAPE 9.6%, R² 0.89</a:t>
             </a:r>
             <a:endParaRPr lang="en-US" sz="1300" dirty="0"/>
           </a:p>
@@ -6192,7 +6192,7 @@
                   <a:schemeClr val="tx2"/>
                 </a:solidFill>
               </a:rPr>
-              <a:t>44 pytest tests passing: API, edge cases, guardrails, vector store, LLM wrapper</a:t>
+              <a:t>64 pytest tests passing: API, edge cases, guardrails, vector store, LLM wrapper</a:t>
             </a:r>
             <a:endParaRPr lang="en-US" sz="1300" dirty="0"/>
           </a:p>
@@ -7499,7 +7499,7 @@
                   <a:schemeClr val="tx1"/>
                 </a:solidFill>
               </a:rPr>
-              <a:t>In production, filters + comp priority reach 84% context precision</a:t>
+              <a:t>In production, filters + comp priority reach 91% context precision</a:t>
             </a:r>
             <a:endParaRPr lang="en-US" sz="1300" dirty="0"/>
           </a:p>

</xml_diff>